<commit_message>
Update Data Semantics Project Report - Fayyaz-946192 .pptx
</commit_message>
<xml_diff>
--- a/Reports/Data Semantics Project Report - Fayyaz-946192 .pptx
+++ b/Reports/Data Semantics Project Report - Fayyaz-946192 .pptx
@@ -2602,7 +2602,7 @@
         </p:nvSpPr>
         <p:spPr>
           <a:xfrm>
-            <a:off x="1313543" y="3474357"/>
+            <a:off x="1313543" y="2955979"/>
             <a:ext cx="6400800" cy="320040"/>
           </a:xfrm>
           <a:prstGeom prst="rect">
@@ -2669,6 +2669,145 @@
               <a:t>Università degli Studi di Milano-Bicocca</a:t>
             </a:r>
             <a:endParaRPr lang="en-US" sz="1000" dirty="0"/>
+          </a:p>
+        </p:txBody>
+      </p:sp>
+      <p:sp>
+        <p:nvSpPr>
+          <p:cNvPr id="15" name="Rectangle: Rounded Corners 14">
+            <a:extLst>
+              <a:ext uri="{FF2B5EF4-FFF2-40B4-BE49-F238E27FC236}">
+                <a16:creationId xmlns:a16="http://schemas.microsoft.com/office/drawing/2014/main" id="{6944639C-0372-A0D9-8E18-D7AF35726D55}"/>
+              </a:ext>
+            </a:extLst>
+          </p:cNvPr>
+          <p:cNvSpPr/>
+          <p:nvPr/>
+        </p:nvSpPr>
+        <p:spPr>
+          <a:xfrm>
+            <a:off x="2376714" y="3483792"/>
+            <a:ext cx="4390572" cy="299285"/>
+          </a:xfrm>
+          <a:prstGeom prst="roundRect">
+            <a:avLst/>
+          </a:prstGeom>
+          <a:ln>
+            <a:noFill/>
+          </a:ln>
+        </p:spPr>
+        <p:style>
+          <a:lnRef idx="2">
+            <a:schemeClr val="accent6"/>
+          </a:lnRef>
+          <a:fillRef idx="1">
+            <a:schemeClr val="lt1"/>
+          </a:fillRef>
+          <a:effectRef idx="0">
+            <a:schemeClr val="accent6"/>
+          </a:effectRef>
+          <a:fontRef idx="minor">
+            <a:schemeClr val="dk1"/>
+          </a:fontRef>
+        </p:style>
+        <p:txBody>
+          <a:bodyPr rtlCol="0" anchor="ctr"/>
+          <a:lstStyle/>
+          <a:p>
+            <a:pPr algn="ctr"/>
+            <a:r>
+              <a:rPr lang="en-US" sz="1200" b="1" dirty="0">
+                <a:solidFill>
+                  <a:schemeClr val="tx1">
+                    <a:lumMod val="65000"/>
+                    <a:lumOff val="35000"/>
+                  </a:schemeClr>
+                </a:solidFill>
+                <a:latin typeface="Calibri" pitchFamily="34" charset="0"/>
+                <a:ea typeface="Calibri" pitchFamily="34" charset="-122"/>
+                <a:cs typeface="Calibri" pitchFamily="34" charset="-120"/>
+              </a:rPr>
+              <a:t>GIT</a:t>
+            </a:r>
+            <a:r>
+              <a:rPr lang="en-US" sz="1200" dirty="0">
+                <a:solidFill>
+                  <a:srgbClr val="CBD5E1"/>
+                </a:solidFill>
+                <a:latin typeface="Calibri" pitchFamily="34" charset="0"/>
+                <a:ea typeface="Calibri" pitchFamily="34" charset="-122"/>
+                <a:cs typeface="Calibri" pitchFamily="34" charset="-120"/>
+              </a:rPr>
+              <a:t>: </a:t>
+            </a:r>
+            <a:r>
+              <a:rPr lang="en-US" sz="1200" dirty="0">
+                <a:solidFill>
+                  <a:srgbClr val="CBD5E1"/>
+                </a:solidFill>
+                <a:latin typeface="Calibri" pitchFamily="34" charset="0"/>
+                <a:ea typeface="Calibri" pitchFamily="34" charset="-122"/>
+                <a:cs typeface="Calibri" pitchFamily="34" charset="-120"/>
+                <a:hlinkClick r:id="rId3"/>
+              </a:rPr>
+              <a:t>https://</a:t>
+            </a:r>
+            <a:r>
+              <a:rPr lang="en-US" sz="1200" dirty="0" err="1">
+                <a:solidFill>
+                  <a:srgbClr val="CBD5E1"/>
+                </a:solidFill>
+                <a:latin typeface="Calibri" pitchFamily="34" charset="0"/>
+                <a:ea typeface="Calibri" pitchFamily="34" charset="-122"/>
+                <a:cs typeface="Calibri" pitchFamily="34" charset="-120"/>
+                <a:hlinkClick r:id="rId3"/>
+              </a:rPr>
+              <a:t>github.com</a:t>
+            </a:r>
+            <a:r>
+              <a:rPr lang="en-US" sz="1200" dirty="0">
+                <a:solidFill>
+                  <a:srgbClr val="CBD5E1"/>
+                </a:solidFill>
+                <a:latin typeface="Calibri" pitchFamily="34" charset="0"/>
+                <a:ea typeface="Calibri" pitchFamily="34" charset="-122"/>
+                <a:cs typeface="Calibri" pitchFamily="34" charset="-120"/>
+                <a:hlinkClick r:id="rId3"/>
+              </a:rPr>
+              <a:t>/</a:t>
+            </a:r>
+            <a:r>
+              <a:rPr lang="en-US" sz="1200" dirty="0" err="1">
+                <a:solidFill>
+                  <a:srgbClr val="CBD5E1"/>
+                </a:solidFill>
+                <a:latin typeface="Calibri" pitchFamily="34" charset="0"/>
+                <a:ea typeface="Calibri" pitchFamily="34" charset="-122"/>
+                <a:cs typeface="Calibri" pitchFamily="34" charset="-120"/>
+                <a:hlinkClick r:id="rId3"/>
+              </a:rPr>
+              <a:t>Fayyaz6137</a:t>
+            </a:r>
+            <a:r>
+              <a:rPr lang="en-US" sz="1200" dirty="0">
+                <a:solidFill>
+                  <a:srgbClr val="CBD5E1"/>
+                </a:solidFill>
+                <a:latin typeface="Calibri" pitchFamily="34" charset="0"/>
+                <a:ea typeface="Calibri" pitchFamily="34" charset="-122"/>
+                <a:cs typeface="Calibri" pitchFamily="34" charset="-120"/>
+                <a:hlinkClick r:id="rId3"/>
+              </a:rPr>
+              <a:t>/Literature-Semantic-Change</a:t>
+            </a:r>
+            <a:endParaRPr lang="en-US" sz="1200" dirty="0">
+              <a:solidFill>
+                <a:srgbClr val="CBD5E1"/>
+              </a:solidFill>
+              <a:latin typeface="Calibri" pitchFamily="34" charset="0"/>
+              <a:ea typeface="Calibri" pitchFamily="34" charset="-122"/>
+              <a:cs typeface="Calibri" pitchFamily="34" charset="-120"/>
+            </a:endParaRPr>
           </a:p>
         </p:txBody>
       </p:sp>

</xml_diff>